<commit_message>
Restructure opening, add TOC/browser slide, center content
Address presenter feedback on the deck:

- Vertically center content on every slide so sparse slides no longer
  leave a large empty band at the bottom
- Tone down the opening message (frame it as a personal reflection, drop
  the swagger highlights) so it reads less boastful
- Add a 目次 (table of contents) after the opening
- Merge the standalone 課題 slide into a single trimmed "作ったもの" slide
  and drop the separate feature list — the app is a few-hours build, so
  it needs little explanation
- Add a slide on everything completing in the browser (static site on
  GitHub, browser VS Code, AI building it)

Co-Authored-By: Claude Opus 4.8 <noreply@anthropic.com>
Claude-Session: https://claude.ai/code/session_01728TbJKawDnZ2kxeR4TCwy
</commit_message>
<xml_diff>
--- a/docs/slides.pptx
+++ b/docs/slides.pptx
@@ -25,10 +25,9 @@
     <p:sldId id="273" r:id="rId19"/>
     <p:sldId id="274" r:id="rId20"/>
     <p:sldId id="275" r:id="rId21"/>
-    <p:sldId id="276" r:id="rId22"/>
   </p:sldIdLst>
   <p:notesMasterIdLst>
-    <p:notesMasterId r:id="rId23"/>
+    <p:notesMasterId r:id="rId22"/>
   </p:notesMasterIdLst>
   <p:sldSz cx="12192000" cy="6858000"/>
   <p:notesSz cx="6858000" cy="12192000"/>
@@ -1602,94 +1601,6 @@
             <a:fld id="{F7021451-1387-4CA6-816F-3879F97B5CBC}" type="slidenum">
               <a:rPr lang="en-US"/>
               <a:t>20</a:t>
-            </a:fld>
-            <a:endParaRPr lang="en-US"/>
-          </a:p>
-        </p:txBody>
-      </p:sp>
-    </p:spTree>
-    <p:extLst>
-      <p:ext uri="{BB962C8B-B14F-4D97-AF65-F5344CB8AC3E}">
-        <p14:creationId xmlns:p14="http://schemas.microsoft.com/office/powerpoint/2010/main" val="1024086991"/>
-      </p:ext>
-    </p:extLst>
-  </p:cSld>
-  <p:clrMapOvr>
-    <a:masterClrMapping/>
-  </p:clrMapOvr>
-</p:notes>
-</file>
-
-<file path=ppt/notesSlides/notesSlide21.xml><?xml version="1.0" encoding="utf-8"?>
-<p:notes xmlns:a="http://schemas.openxmlformats.org/drawingml/2006/main" xmlns:r="http://schemas.openxmlformats.org/officeDocument/2006/relationships" xmlns:p="http://schemas.openxmlformats.org/presentationml/2006/main">
-  <p:cSld>
-    <p:spTree>
-      <p:nvGrpSpPr>
-        <p:cNvPr id="1" name=""/>
-        <p:cNvGrpSpPr/>
-        <p:nvPr/>
-      </p:nvGrpSpPr>
-      <p:grpSpPr>
-        <a:xfrm>
-          <a:off x="0" y="0"/>
-          <a:ext cx="0" cy="0"/>
-          <a:chOff x="0" y="0"/>
-          <a:chExt cx="0" cy="0"/>
-        </a:xfrm>
-      </p:grpSpPr>
-      <p:sp>
-        <p:nvSpPr>
-          <p:cNvPr id="2" name="Slide Image Placeholder 1"/>
-          <p:cNvSpPr>
-            <a:spLocks noGrp="1" noRot="1" noChangeAspect="1"/>
-          </p:cNvSpPr>
-          <p:nvPr>
-            <p:ph type="sldImg"/>
-          </p:nvPr>
-        </p:nvSpPr>
-        <p:spPr/>
-      </p:sp>
-      <p:sp>
-        <p:nvSpPr>
-          <p:cNvPr id="3" name="Notes Placeholder 2"/>
-          <p:cNvSpPr>
-            <a:spLocks noGrp="1"/>
-          </p:cNvSpPr>
-          <p:nvPr>
-            <p:ph type="body" idx="1"/>
-          </p:nvPr>
-        </p:nvSpPr>
-        <p:spPr/>
-        <p:txBody>
-          <a:bodyPr/>
-          <a:lstStyle/>
-          <a:p>
-            <a:r>
-              <a:rPr lang="en-US" dirty="0"/>
-              <a:t/>
-            </a:r>
-            <a:endParaRPr lang="en-US" dirty="0"/>
-          </a:p>
-        </p:txBody>
-      </p:sp>
-      <p:sp>
-        <p:nvSpPr>
-          <p:cNvPr id="4" name="Slide Number Placeholder 3"/>
-          <p:cNvSpPr>
-            <a:spLocks noGrp="1"/>
-          </p:cNvSpPr>
-          <p:nvPr>
-            <p:ph type="sldNum" sz="quarter" idx="10"/>
-          </p:nvPr>
-        </p:nvSpPr>
-        <p:spPr/>
-        <p:txBody>
-          <a:bodyPr/>
-          <a:lstStyle/>
-          <a:p>
-            <a:fld id="{F7021451-1387-4CA6-816F-3879F97B5CBC}" type="slidenum">
-              <a:rPr lang="en-US"/>
-              <a:t>21</a:t>
             </a:fld>
             <a:endParaRPr lang="en-US"/>
           </a:p>
@@ -3102,45 +3013,6 @@
 <file path=ppt/slides/slide20.xml><?xml version="1.0" encoding="utf-8"?>
 <p:sld xmlns:a="http://schemas.openxmlformats.org/drawingml/2006/main" xmlns:r="http://schemas.openxmlformats.org/officeDocument/2006/relationships" xmlns:p="http://schemas.openxmlformats.org/presentationml/2006/main">
   <p:cSld name="Slide 20">
-    <p:bg>
-      <p:bgPr>
-        <a:blipFill dpi="0" rotWithShape="1">
-          <a:blip r:embed="rId1">
-            <a:lum/>
-          </a:blip>
-          <a:srcRect/>
-          <a:stretch>
-            <a:fillRect/>
-          </a:stretch>
-        </a:blipFill>
-        <a:effectLst/>
-      </p:bgPr>
-    </p:bg>
-    <p:spTree>
-      <p:nvGrpSpPr>
-        <p:cNvPr id="1" name=""/>
-        <p:cNvGrpSpPr/>
-        <p:nvPr/>
-      </p:nvGrpSpPr>
-      <p:grpSpPr>
-        <a:xfrm>
-          <a:off x="0" y="0"/>
-          <a:ext cx="0" cy="0"/>
-          <a:chOff x="0" y="0"/>
-          <a:chExt cx="0" cy="0"/>
-        </a:xfrm>
-      </p:grpSpPr>
-    </p:spTree>
-  </p:cSld>
-  <p:clrMapOvr>
-    <a:masterClrMapping/>
-  </p:clrMapOvr>
-</p:sld>
-</file>
-
-<file path=ppt/slides/slide21.xml><?xml version="1.0" encoding="utf-8"?>
-<p:sld xmlns:a="http://schemas.openxmlformats.org/drawingml/2006/main" xmlns:r="http://schemas.openxmlformats.org/officeDocument/2006/relationships" xmlns:p="http://schemas.openxmlformats.org/presentationml/2006/main">
-  <p:cSld name="Slide 21">
     <p:bg>
       <p:bgPr>
         <a:blipFill dpi="0" rotWithShape="1">

</xml_diff>

<commit_message>
Simplify deck to a plain, professional style
Rework the deck into a conventional business/technical presentation per
feedback: remove the large "message" slides, marker highlights, and
colloquial/dramatic phrasing; use plain topic headings and neutral
declarative copy. Reduce to 11 slides.

- White background, anchored headings, plain bullet lists
- Four concise "学んだこと" slides (verify AI output, "works" vs "correct",
  data preparation cost, where value shifts) plus the value-shift diagram
- Trim to: title, TOC, 課題と要件, 作ったもの, 開発方法, 4 learnings,
  まとめ, 付録

Co-Authored-By: Claude Opus 4.8 <noreply@anthropic.com>
Claude-Session: https://claude.ai/code/session_01728TbJKawDnZ2kxeR4TCwy
</commit_message>
<xml_diff>
--- a/docs/slides.pptx
+++ b/docs/slides.pptx
@@ -16,18 +16,9 @@
     <p:sldId id="264" r:id="rId10"/>
     <p:sldId id="265" r:id="rId11"/>
     <p:sldId id="266" r:id="rId12"/>
-    <p:sldId id="267" r:id="rId13"/>
-    <p:sldId id="268" r:id="rId14"/>
-    <p:sldId id="269" r:id="rId15"/>
-    <p:sldId id="270" r:id="rId16"/>
-    <p:sldId id="271" r:id="rId17"/>
-    <p:sldId id="272" r:id="rId18"/>
-    <p:sldId id="273" r:id="rId19"/>
-    <p:sldId id="274" r:id="rId20"/>
-    <p:sldId id="275" r:id="rId21"/>
   </p:sldIdLst>
   <p:notesMasterIdLst>
-    <p:notesMasterId r:id="rId22"/>
+    <p:notesMasterId r:id="rId13"/>
   </p:notesMasterIdLst>
   <p:sldSz cx="12192000" cy="6858000"/>
   <p:notesSz cx="6858000" cy="12192000"/>
@@ -739,710 +730,6 @@
 </p:notes>
 </file>
 
-<file path=ppt/notesSlides/notesSlide12.xml><?xml version="1.0" encoding="utf-8"?>
-<p:notes xmlns:a="http://schemas.openxmlformats.org/drawingml/2006/main" xmlns:r="http://schemas.openxmlformats.org/officeDocument/2006/relationships" xmlns:p="http://schemas.openxmlformats.org/presentationml/2006/main">
-  <p:cSld>
-    <p:spTree>
-      <p:nvGrpSpPr>
-        <p:cNvPr id="1" name=""/>
-        <p:cNvGrpSpPr/>
-        <p:nvPr/>
-      </p:nvGrpSpPr>
-      <p:grpSpPr>
-        <a:xfrm>
-          <a:off x="0" y="0"/>
-          <a:ext cx="0" cy="0"/>
-          <a:chOff x="0" y="0"/>
-          <a:chExt cx="0" cy="0"/>
-        </a:xfrm>
-      </p:grpSpPr>
-      <p:sp>
-        <p:nvSpPr>
-          <p:cNvPr id="2" name="Slide Image Placeholder 1"/>
-          <p:cNvSpPr>
-            <a:spLocks noGrp="1" noRot="1" noChangeAspect="1"/>
-          </p:cNvSpPr>
-          <p:nvPr>
-            <p:ph type="sldImg"/>
-          </p:nvPr>
-        </p:nvSpPr>
-        <p:spPr/>
-      </p:sp>
-      <p:sp>
-        <p:nvSpPr>
-          <p:cNvPr id="3" name="Notes Placeholder 2"/>
-          <p:cNvSpPr>
-            <a:spLocks noGrp="1"/>
-          </p:cNvSpPr>
-          <p:nvPr>
-            <p:ph type="body" idx="1"/>
-          </p:nvPr>
-        </p:nvSpPr>
-        <p:spPr/>
-        <p:txBody>
-          <a:bodyPr/>
-          <a:lstStyle/>
-          <a:p>
-            <a:r>
-              <a:rPr lang="en-US" dirty="0"/>
-              <a:t/>
-            </a:r>
-            <a:endParaRPr lang="en-US" dirty="0"/>
-          </a:p>
-        </p:txBody>
-      </p:sp>
-      <p:sp>
-        <p:nvSpPr>
-          <p:cNvPr id="4" name="Slide Number Placeholder 3"/>
-          <p:cNvSpPr>
-            <a:spLocks noGrp="1"/>
-          </p:cNvSpPr>
-          <p:nvPr>
-            <p:ph type="sldNum" sz="quarter" idx="10"/>
-          </p:nvPr>
-        </p:nvSpPr>
-        <p:spPr/>
-        <p:txBody>
-          <a:bodyPr/>
-          <a:lstStyle/>
-          <a:p>
-            <a:fld id="{F7021451-1387-4CA6-816F-3879F97B5CBC}" type="slidenum">
-              <a:rPr lang="en-US"/>
-              <a:t>12</a:t>
-            </a:fld>
-            <a:endParaRPr lang="en-US"/>
-          </a:p>
-        </p:txBody>
-      </p:sp>
-    </p:spTree>
-    <p:extLst>
-      <p:ext uri="{BB962C8B-B14F-4D97-AF65-F5344CB8AC3E}">
-        <p14:creationId xmlns:p14="http://schemas.microsoft.com/office/powerpoint/2010/main" val="1024086991"/>
-      </p:ext>
-    </p:extLst>
-  </p:cSld>
-  <p:clrMapOvr>
-    <a:masterClrMapping/>
-  </p:clrMapOvr>
-</p:notes>
-</file>
-
-<file path=ppt/notesSlides/notesSlide13.xml><?xml version="1.0" encoding="utf-8"?>
-<p:notes xmlns:a="http://schemas.openxmlformats.org/drawingml/2006/main" xmlns:r="http://schemas.openxmlformats.org/officeDocument/2006/relationships" xmlns:p="http://schemas.openxmlformats.org/presentationml/2006/main">
-  <p:cSld>
-    <p:spTree>
-      <p:nvGrpSpPr>
-        <p:cNvPr id="1" name=""/>
-        <p:cNvGrpSpPr/>
-        <p:nvPr/>
-      </p:nvGrpSpPr>
-      <p:grpSpPr>
-        <a:xfrm>
-          <a:off x="0" y="0"/>
-          <a:ext cx="0" cy="0"/>
-          <a:chOff x="0" y="0"/>
-          <a:chExt cx="0" cy="0"/>
-        </a:xfrm>
-      </p:grpSpPr>
-      <p:sp>
-        <p:nvSpPr>
-          <p:cNvPr id="2" name="Slide Image Placeholder 1"/>
-          <p:cNvSpPr>
-            <a:spLocks noGrp="1" noRot="1" noChangeAspect="1"/>
-          </p:cNvSpPr>
-          <p:nvPr>
-            <p:ph type="sldImg"/>
-          </p:nvPr>
-        </p:nvSpPr>
-        <p:spPr/>
-      </p:sp>
-      <p:sp>
-        <p:nvSpPr>
-          <p:cNvPr id="3" name="Notes Placeholder 2"/>
-          <p:cNvSpPr>
-            <a:spLocks noGrp="1"/>
-          </p:cNvSpPr>
-          <p:nvPr>
-            <p:ph type="body" idx="1"/>
-          </p:nvPr>
-        </p:nvSpPr>
-        <p:spPr/>
-        <p:txBody>
-          <a:bodyPr/>
-          <a:lstStyle/>
-          <a:p>
-            <a:r>
-              <a:rPr lang="en-US" dirty="0"/>
-              <a:t/>
-            </a:r>
-            <a:endParaRPr lang="en-US" dirty="0"/>
-          </a:p>
-        </p:txBody>
-      </p:sp>
-      <p:sp>
-        <p:nvSpPr>
-          <p:cNvPr id="4" name="Slide Number Placeholder 3"/>
-          <p:cNvSpPr>
-            <a:spLocks noGrp="1"/>
-          </p:cNvSpPr>
-          <p:nvPr>
-            <p:ph type="sldNum" sz="quarter" idx="10"/>
-          </p:nvPr>
-        </p:nvSpPr>
-        <p:spPr/>
-        <p:txBody>
-          <a:bodyPr/>
-          <a:lstStyle/>
-          <a:p>
-            <a:fld id="{F7021451-1387-4CA6-816F-3879F97B5CBC}" type="slidenum">
-              <a:rPr lang="en-US"/>
-              <a:t>13</a:t>
-            </a:fld>
-            <a:endParaRPr lang="en-US"/>
-          </a:p>
-        </p:txBody>
-      </p:sp>
-    </p:spTree>
-    <p:extLst>
-      <p:ext uri="{BB962C8B-B14F-4D97-AF65-F5344CB8AC3E}">
-        <p14:creationId xmlns:p14="http://schemas.microsoft.com/office/powerpoint/2010/main" val="1024086991"/>
-      </p:ext>
-    </p:extLst>
-  </p:cSld>
-  <p:clrMapOvr>
-    <a:masterClrMapping/>
-  </p:clrMapOvr>
-</p:notes>
-</file>
-
-<file path=ppt/notesSlides/notesSlide14.xml><?xml version="1.0" encoding="utf-8"?>
-<p:notes xmlns:a="http://schemas.openxmlformats.org/drawingml/2006/main" xmlns:r="http://schemas.openxmlformats.org/officeDocument/2006/relationships" xmlns:p="http://schemas.openxmlformats.org/presentationml/2006/main">
-  <p:cSld>
-    <p:spTree>
-      <p:nvGrpSpPr>
-        <p:cNvPr id="1" name=""/>
-        <p:cNvGrpSpPr/>
-        <p:nvPr/>
-      </p:nvGrpSpPr>
-      <p:grpSpPr>
-        <a:xfrm>
-          <a:off x="0" y="0"/>
-          <a:ext cx="0" cy="0"/>
-          <a:chOff x="0" y="0"/>
-          <a:chExt cx="0" cy="0"/>
-        </a:xfrm>
-      </p:grpSpPr>
-      <p:sp>
-        <p:nvSpPr>
-          <p:cNvPr id="2" name="Slide Image Placeholder 1"/>
-          <p:cNvSpPr>
-            <a:spLocks noGrp="1" noRot="1" noChangeAspect="1"/>
-          </p:cNvSpPr>
-          <p:nvPr>
-            <p:ph type="sldImg"/>
-          </p:nvPr>
-        </p:nvSpPr>
-        <p:spPr/>
-      </p:sp>
-      <p:sp>
-        <p:nvSpPr>
-          <p:cNvPr id="3" name="Notes Placeholder 2"/>
-          <p:cNvSpPr>
-            <a:spLocks noGrp="1"/>
-          </p:cNvSpPr>
-          <p:nvPr>
-            <p:ph type="body" idx="1"/>
-          </p:nvPr>
-        </p:nvSpPr>
-        <p:spPr/>
-        <p:txBody>
-          <a:bodyPr/>
-          <a:lstStyle/>
-          <a:p>
-            <a:r>
-              <a:rPr lang="en-US" dirty="0"/>
-              <a:t/>
-            </a:r>
-            <a:endParaRPr lang="en-US" dirty="0"/>
-          </a:p>
-        </p:txBody>
-      </p:sp>
-      <p:sp>
-        <p:nvSpPr>
-          <p:cNvPr id="4" name="Slide Number Placeholder 3"/>
-          <p:cNvSpPr>
-            <a:spLocks noGrp="1"/>
-          </p:cNvSpPr>
-          <p:nvPr>
-            <p:ph type="sldNum" sz="quarter" idx="10"/>
-          </p:nvPr>
-        </p:nvSpPr>
-        <p:spPr/>
-        <p:txBody>
-          <a:bodyPr/>
-          <a:lstStyle/>
-          <a:p>
-            <a:fld id="{F7021451-1387-4CA6-816F-3879F97B5CBC}" type="slidenum">
-              <a:rPr lang="en-US"/>
-              <a:t>14</a:t>
-            </a:fld>
-            <a:endParaRPr lang="en-US"/>
-          </a:p>
-        </p:txBody>
-      </p:sp>
-    </p:spTree>
-    <p:extLst>
-      <p:ext uri="{BB962C8B-B14F-4D97-AF65-F5344CB8AC3E}">
-        <p14:creationId xmlns:p14="http://schemas.microsoft.com/office/powerpoint/2010/main" val="1024086991"/>
-      </p:ext>
-    </p:extLst>
-  </p:cSld>
-  <p:clrMapOvr>
-    <a:masterClrMapping/>
-  </p:clrMapOvr>
-</p:notes>
-</file>
-
-<file path=ppt/notesSlides/notesSlide15.xml><?xml version="1.0" encoding="utf-8"?>
-<p:notes xmlns:a="http://schemas.openxmlformats.org/drawingml/2006/main" xmlns:r="http://schemas.openxmlformats.org/officeDocument/2006/relationships" xmlns:p="http://schemas.openxmlformats.org/presentationml/2006/main">
-  <p:cSld>
-    <p:spTree>
-      <p:nvGrpSpPr>
-        <p:cNvPr id="1" name=""/>
-        <p:cNvGrpSpPr/>
-        <p:nvPr/>
-      </p:nvGrpSpPr>
-      <p:grpSpPr>
-        <a:xfrm>
-          <a:off x="0" y="0"/>
-          <a:ext cx="0" cy="0"/>
-          <a:chOff x="0" y="0"/>
-          <a:chExt cx="0" cy="0"/>
-        </a:xfrm>
-      </p:grpSpPr>
-      <p:sp>
-        <p:nvSpPr>
-          <p:cNvPr id="2" name="Slide Image Placeholder 1"/>
-          <p:cNvSpPr>
-            <a:spLocks noGrp="1" noRot="1" noChangeAspect="1"/>
-          </p:cNvSpPr>
-          <p:nvPr>
-            <p:ph type="sldImg"/>
-          </p:nvPr>
-        </p:nvSpPr>
-        <p:spPr/>
-      </p:sp>
-      <p:sp>
-        <p:nvSpPr>
-          <p:cNvPr id="3" name="Notes Placeholder 2"/>
-          <p:cNvSpPr>
-            <a:spLocks noGrp="1"/>
-          </p:cNvSpPr>
-          <p:nvPr>
-            <p:ph type="body" idx="1"/>
-          </p:nvPr>
-        </p:nvSpPr>
-        <p:spPr/>
-        <p:txBody>
-          <a:bodyPr/>
-          <a:lstStyle/>
-          <a:p>
-            <a:r>
-              <a:rPr lang="en-US" dirty="0"/>
-              <a:t/>
-            </a:r>
-            <a:endParaRPr lang="en-US" dirty="0"/>
-          </a:p>
-        </p:txBody>
-      </p:sp>
-      <p:sp>
-        <p:nvSpPr>
-          <p:cNvPr id="4" name="Slide Number Placeholder 3"/>
-          <p:cNvSpPr>
-            <a:spLocks noGrp="1"/>
-          </p:cNvSpPr>
-          <p:nvPr>
-            <p:ph type="sldNum" sz="quarter" idx="10"/>
-          </p:nvPr>
-        </p:nvSpPr>
-        <p:spPr/>
-        <p:txBody>
-          <a:bodyPr/>
-          <a:lstStyle/>
-          <a:p>
-            <a:fld id="{F7021451-1387-4CA6-816F-3879F97B5CBC}" type="slidenum">
-              <a:rPr lang="en-US"/>
-              <a:t>15</a:t>
-            </a:fld>
-            <a:endParaRPr lang="en-US"/>
-          </a:p>
-        </p:txBody>
-      </p:sp>
-    </p:spTree>
-    <p:extLst>
-      <p:ext uri="{BB962C8B-B14F-4D97-AF65-F5344CB8AC3E}">
-        <p14:creationId xmlns:p14="http://schemas.microsoft.com/office/powerpoint/2010/main" val="1024086991"/>
-      </p:ext>
-    </p:extLst>
-  </p:cSld>
-  <p:clrMapOvr>
-    <a:masterClrMapping/>
-  </p:clrMapOvr>
-</p:notes>
-</file>
-
-<file path=ppt/notesSlides/notesSlide16.xml><?xml version="1.0" encoding="utf-8"?>
-<p:notes xmlns:a="http://schemas.openxmlformats.org/drawingml/2006/main" xmlns:r="http://schemas.openxmlformats.org/officeDocument/2006/relationships" xmlns:p="http://schemas.openxmlformats.org/presentationml/2006/main">
-  <p:cSld>
-    <p:spTree>
-      <p:nvGrpSpPr>
-        <p:cNvPr id="1" name=""/>
-        <p:cNvGrpSpPr/>
-        <p:nvPr/>
-      </p:nvGrpSpPr>
-      <p:grpSpPr>
-        <a:xfrm>
-          <a:off x="0" y="0"/>
-          <a:ext cx="0" cy="0"/>
-          <a:chOff x="0" y="0"/>
-          <a:chExt cx="0" cy="0"/>
-        </a:xfrm>
-      </p:grpSpPr>
-      <p:sp>
-        <p:nvSpPr>
-          <p:cNvPr id="2" name="Slide Image Placeholder 1"/>
-          <p:cNvSpPr>
-            <a:spLocks noGrp="1" noRot="1" noChangeAspect="1"/>
-          </p:cNvSpPr>
-          <p:nvPr>
-            <p:ph type="sldImg"/>
-          </p:nvPr>
-        </p:nvSpPr>
-        <p:spPr/>
-      </p:sp>
-      <p:sp>
-        <p:nvSpPr>
-          <p:cNvPr id="3" name="Notes Placeholder 2"/>
-          <p:cNvSpPr>
-            <a:spLocks noGrp="1"/>
-          </p:cNvSpPr>
-          <p:nvPr>
-            <p:ph type="body" idx="1"/>
-          </p:nvPr>
-        </p:nvSpPr>
-        <p:spPr/>
-        <p:txBody>
-          <a:bodyPr/>
-          <a:lstStyle/>
-          <a:p>
-            <a:r>
-              <a:rPr lang="en-US" dirty="0"/>
-              <a:t/>
-            </a:r>
-            <a:endParaRPr lang="en-US" dirty="0"/>
-          </a:p>
-        </p:txBody>
-      </p:sp>
-      <p:sp>
-        <p:nvSpPr>
-          <p:cNvPr id="4" name="Slide Number Placeholder 3"/>
-          <p:cNvSpPr>
-            <a:spLocks noGrp="1"/>
-          </p:cNvSpPr>
-          <p:nvPr>
-            <p:ph type="sldNum" sz="quarter" idx="10"/>
-          </p:nvPr>
-        </p:nvSpPr>
-        <p:spPr/>
-        <p:txBody>
-          <a:bodyPr/>
-          <a:lstStyle/>
-          <a:p>
-            <a:fld id="{F7021451-1387-4CA6-816F-3879F97B5CBC}" type="slidenum">
-              <a:rPr lang="en-US"/>
-              <a:t>16</a:t>
-            </a:fld>
-            <a:endParaRPr lang="en-US"/>
-          </a:p>
-        </p:txBody>
-      </p:sp>
-    </p:spTree>
-    <p:extLst>
-      <p:ext uri="{BB962C8B-B14F-4D97-AF65-F5344CB8AC3E}">
-        <p14:creationId xmlns:p14="http://schemas.microsoft.com/office/powerpoint/2010/main" val="1024086991"/>
-      </p:ext>
-    </p:extLst>
-  </p:cSld>
-  <p:clrMapOvr>
-    <a:masterClrMapping/>
-  </p:clrMapOvr>
-</p:notes>
-</file>
-
-<file path=ppt/notesSlides/notesSlide17.xml><?xml version="1.0" encoding="utf-8"?>
-<p:notes xmlns:a="http://schemas.openxmlformats.org/drawingml/2006/main" xmlns:r="http://schemas.openxmlformats.org/officeDocument/2006/relationships" xmlns:p="http://schemas.openxmlformats.org/presentationml/2006/main">
-  <p:cSld>
-    <p:spTree>
-      <p:nvGrpSpPr>
-        <p:cNvPr id="1" name=""/>
-        <p:cNvGrpSpPr/>
-        <p:nvPr/>
-      </p:nvGrpSpPr>
-      <p:grpSpPr>
-        <a:xfrm>
-          <a:off x="0" y="0"/>
-          <a:ext cx="0" cy="0"/>
-          <a:chOff x="0" y="0"/>
-          <a:chExt cx="0" cy="0"/>
-        </a:xfrm>
-      </p:grpSpPr>
-      <p:sp>
-        <p:nvSpPr>
-          <p:cNvPr id="2" name="Slide Image Placeholder 1"/>
-          <p:cNvSpPr>
-            <a:spLocks noGrp="1" noRot="1" noChangeAspect="1"/>
-          </p:cNvSpPr>
-          <p:nvPr>
-            <p:ph type="sldImg"/>
-          </p:nvPr>
-        </p:nvSpPr>
-        <p:spPr/>
-      </p:sp>
-      <p:sp>
-        <p:nvSpPr>
-          <p:cNvPr id="3" name="Notes Placeholder 2"/>
-          <p:cNvSpPr>
-            <a:spLocks noGrp="1"/>
-          </p:cNvSpPr>
-          <p:nvPr>
-            <p:ph type="body" idx="1"/>
-          </p:nvPr>
-        </p:nvSpPr>
-        <p:spPr/>
-        <p:txBody>
-          <a:bodyPr/>
-          <a:lstStyle/>
-          <a:p>
-            <a:r>
-              <a:rPr lang="en-US" dirty="0"/>
-              <a:t/>
-            </a:r>
-            <a:endParaRPr lang="en-US" dirty="0"/>
-          </a:p>
-        </p:txBody>
-      </p:sp>
-      <p:sp>
-        <p:nvSpPr>
-          <p:cNvPr id="4" name="Slide Number Placeholder 3"/>
-          <p:cNvSpPr>
-            <a:spLocks noGrp="1"/>
-          </p:cNvSpPr>
-          <p:nvPr>
-            <p:ph type="sldNum" sz="quarter" idx="10"/>
-          </p:nvPr>
-        </p:nvSpPr>
-        <p:spPr/>
-        <p:txBody>
-          <a:bodyPr/>
-          <a:lstStyle/>
-          <a:p>
-            <a:fld id="{F7021451-1387-4CA6-816F-3879F97B5CBC}" type="slidenum">
-              <a:rPr lang="en-US"/>
-              <a:t>17</a:t>
-            </a:fld>
-            <a:endParaRPr lang="en-US"/>
-          </a:p>
-        </p:txBody>
-      </p:sp>
-    </p:spTree>
-    <p:extLst>
-      <p:ext uri="{BB962C8B-B14F-4D97-AF65-F5344CB8AC3E}">
-        <p14:creationId xmlns:p14="http://schemas.microsoft.com/office/powerpoint/2010/main" val="1024086991"/>
-      </p:ext>
-    </p:extLst>
-  </p:cSld>
-  <p:clrMapOvr>
-    <a:masterClrMapping/>
-  </p:clrMapOvr>
-</p:notes>
-</file>
-
-<file path=ppt/notesSlides/notesSlide18.xml><?xml version="1.0" encoding="utf-8"?>
-<p:notes xmlns:a="http://schemas.openxmlformats.org/drawingml/2006/main" xmlns:r="http://schemas.openxmlformats.org/officeDocument/2006/relationships" xmlns:p="http://schemas.openxmlformats.org/presentationml/2006/main">
-  <p:cSld>
-    <p:spTree>
-      <p:nvGrpSpPr>
-        <p:cNvPr id="1" name=""/>
-        <p:cNvGrpSpPr/>
-        <p:nvPr/>
-      </p:nvGrpSpPr>
-      <p:grpSpPr>
-        <a:xfrm>
-          <a:off x="0" y="0"/>
-          <a:ext cx="0" cy="0"/>
-          <a:chOff x="0" y="0"/>
-          <a:chExt cx="0" cy="0"/>
-        </a:xfrm>
-      </p:grpSpPr>
-      <p:sp>
-        <p:nvSpPr>
-          <p:cNvPr id="2" name="Slide Image Placeholder 1"/>
-          <p:cNvSpPr>
-            <a:spLocks noGrp="1" noRot="1" noChangeAspect="1"/>
-          </p:cNvSpPr>
-          <p:nvPr>
-            <p:ph type="sldImg"/>
-          </p:nvPr>
-        </p:nvSpPr>
-        <p:spPr/>
-      </p:sp>
-      <p:sp>
-        <p:nvSpPr>
-          <p:cNvPr id="3" name="Notes Placeholder 2"/>
-          <p:cNvSpPr>
-            <a:spLocks noGrp="1"/>
-          </p:cNvSpPr>
-          <p:nvPr>
-            <p:ph type="body" idx="1"/>
-          </p:nvPr>
-        </p:nvSpPr>
-        <p:spPr/>
-        <p:txBody>
-          <a:bodyPr/>
-          <a:lstStyle/>
-          <a:p>
-            <a:r>
-              <a:rPr lang="en-US" dirty="0"/>
-              <a:t/>
-            </a:r>
-            <a:endParaRPr lang="en-US" dirty="0"/>
-          </a:p>
-        </p:txBody>
-      </p:sp>
-      <p:sp>
-        <p:nvSpPr>
-          <p:cNvPr id="4" name="Slide Number Placeholder 3"/>
-          <p:cNvSpPr>
-            <a:spLocks noGrp="1"/>
-          </p:cNvSpPr>
-          <p:nvPr>
-            <p:ph type="sldNum" sz="quarter" idx="10"/>
-          </p:nvPr>
-        </p:nvSpPr>
-        <p:spPr/>
-        <p:txBody>
-          <a:bodyPr/>
-          <a:lstStyle/>
-          <a:p>
-            <a:fld id="{F7021451-1387-4CA6-816F-3879F97B5CBC}" type="slidenum">
-              <a:rPr lang="en-US"/>
-              <a:t>18</a:t>
-            </a:fld>
-            <a:endParaRPr lang="en-US"/>
-          </a:p>
-        </p:txBody>
-      </p:sp>
-    </p:spTree>
-    <p:extLst>
-      <p:ext uri="{BB962C8B-B14F-4D97-AF65-F5344CB8AC3E}">
-        <p14:creationId xmlns:p14="http://schemas.microsoft.com/office/powerpoint/2010/main" val="1024086991"/>
-      </p:ext>
-    </p:extLst>
-  </p:cSld>
-  <p:clrMapOvr>
-    <a:masterClrMapping/>
-  </p:clrMapOvr>
-</p:notes>
-</file>
-
-<file path=ppt/notesSlides/notesSlide19.xml><?xml version="1.0" encoding="utf-8"?>
-<p:notes xmlns:a="http://schemas.openxmlformats.org/drawingml/2006/main" xmlns:r="http://schemas.openxmlformats.org/officeDocument/2006/relationships" xmlns:p="http://schemas.openxmlformats.org/presentationml/2006/main">
-  <p:cSld>
-    <p:spTree>
-      <p:nvGrpSpPr>
-        <p:cNvPr id="1" name=""/>
-        <p:cNvGrpSpPr/>
-        <p:nvPr/>
-      </p:nvGrpSpPr>
-      <p:grpSpPr>
-        <a:xfrm>
-          <a:off x="0" y="0"/>
-          <a:ext cx="0" cy="0"/>
-          <a:chOff x="0" y="0"/>
-          <a:chExt cx="0" cy="0"/>
-        </a:xfrm>
-      </p:grpSpPr>
-      <p:sp>
-        <p:nvSpPr>
-          <p:cNvPr id="2" name="Slide Image Placeholder 1"/>
-          <p:cNvSpPr>
-            <a:spLocks noGrp="1" noRot="1" noChangeAspect="1"/>
-          </p:cNvSpPr>
-          <p:nvPr>
-            <p:ph type="sldImg"/>
-          </p:nvPr>
-        </p:nvSpPr>
-        <p:spPr/>
-      </p:sp>
-      <p:sp>
-        <p:nvSpPr>
-          <p:cNvPr id="3" name="Notes Placeholder 2"/>
-          <p:cNvSpPr>
-            <a:spLocks noGrp="1"/>
-          </p:cNvSpPr>
-          <p:nvPr>
-            <p:ph type="body" idx="1"/>
-          </p:nvPr>
-        </p:nvSpPr>
-        <p:spPr/>
-        <p:txBody>
-          <a:bodyPr/>
-          <a:lstStyle/>
-          <a:p>
-            <a:r>
-              <a:rPr lang="en-US" dirty="0"/>
-              <a:t/>
-            </a:r>
-            <a:endParaRPr lang="en-US" dirty="0"/>
-          </a:p>
-        </p:txBody>
-      </p:sp>
-      <p:sp>
-        <p:nvSpPr>
-          <p:cNvPr id="4" name="Slide Number Placeholder 3"/>
-          <p:cNvSpPr>
-            <a:spLocks noGrp="1"/>
-          </p:cNvSpPr>
-          <p:nvPr>
-            <p:ph type="sldNum" sz="quarter" idx="10"/>
-          </p:nvPr>
-        </p:nvSpPr>
-        <p:spPr/>
-        <p:txBody>
-          <a:bodyPr/>
-          <a:lstStyle/>
-          <a:p>
-            <a:fld id="{F7021451-1387-4CA6-816F-3879F97B5CBC}" type="slidenum">
-              <a:rPr lang="en-US"/>
-              <a:t>19</a:t>
-            </a:fld>
-            <a:endParaRPr lang="en-US"/>
-          </a:p>
-        </p:txBody>
-      </p:sp>
-    </p:spTree>
-    <p:extLst>
-      <p:ext uri="{BB962C8B-B14F-4D97-AF65-F5344CB8AC3E}">
-        <p14:creationId xmlns:p14="http://schemas.microsoft.com/office/powerpoint/2010/main" val="1024086991"/>
-      </p:ext>
-    </p:extLst>
-  </p:cSld>
-  <p:clrMapOvr>
-    <a:masterClrMapping/>
-  </p:clrMapOvr>
-</p:notes>
-</file>
-
 <file path=ppt/notesSlides/notesSlide2.xml><?xml version="1.0" encoding="utf-8"?>
 <p:notes xmlns:a="http://schemas.openxmlformats.org/drawingml/2006/main" xmlns:r="http://schemas.openxmlformats.org/officeDocument/2006/relationships" xmlns:p="http://schemas.openxmlformats.org/presentationml/2006/main">
   <p:cSld>
@@ -1513,94 +800,6 @@
             <a:fld id="{F7021451-1387-4CA6-816F-3879F97B5CBC}" type="slidenum">
               <a:rPr lang="en-US"/>
               <a:t>2</a:t>
-            </a:fld>
-            <a:endParaRPr lang="en-US"/>
-          </a:p>
-        </p:txBody>
-      </p:sp>
-    </p:spTree>
-    <p:extLst>
-      <p:ext uri="{BB962C8B-B14F-4D97-AF65-F5344CB8AC3E}">
-        <p14:creationId xmlns:p14="http://schemas.microsoft.com/office/powerpoint/2010/main" val="1024086991"/>
-      </p:ext>
-    </p:extLst>
-  </p:cSld>
-  <p:clrMapOvr>
-    <a:masterClrMapping/>
-  </p:clrMapOvr>
-</p:notes>
-</file>
-
-<file path=ppt/notesSlides/notesSlide20.xml><?xml version="1.0" encoding="utf-8"?>
-<p:notes xmlns:a="http://schemas.openxmlformats.org/drawingml/2006/main" xmlns:r="http://schemas.openxmlformats.org/officeDocument/2006/relationships" xmlns:p="http://schemas.openxmlformats.org/presentationml/2006/main">
-  <p:cSld>
-    <p:spTree>
-      <p:nvGrpSpPr>
-        <p:cNvPr id="1" name=""/>
-        <p:cNvGrpSpPr/>
-        <p:nvPr/>
-      </p:nvGrpSpPr>
-      <p:grpSpPr>
-        <a:xfrm>
-          <a:off x="0" y="0"/>
-          <a:ext cx="0" cy="0"/>
-          <a:chOff x="0" y="0"/>
-          <a:chExt cx="0" cy="0"/>
-        </a:xfrm>
-      </p:grpSpPr>
-      <p:sp>
-        <p:nvSpPr>
-          <p:cNvPr id="2" name="Slide Image Placeholder 1"/>
-          <p:cNvSpPr>
-            <a:spLocks noGrp="1" noRot="1" noChangeAspect="1"/>
-          </p:cNvSpPr>
-          <p:nvPr>
-            <p:ph type="sldImg"/>
-          </p:nvPr>
-        </p:nvSpPr>
-        <p:spPr/>
-      </p:sp>
-      <p:sp>
-        <p:nvSpPr>
-          <p:cNvPr id="3" name="Notes Placeholder 2"/>
-          <p:cNvSpPr>
-            <a:spLocks noGrp="1"/>
-          </p:cNvSpPr>
-          <p:nvPr>
-            <p:ph type="body" idx="1"/>
-          </p:nvPr>
-        </p:nvSpPr>
-        <p:spPr/>
-        <p:txBody>
-          <a:bodyPr/>
-          <a:lstStyle/>
-          <a:p>
-            <a:r>
-              <a:rPr lang="en-US" dirty="0"/>
-              <a:t/>
-            </a:r>
-            <a:endParaRPr lang="en-US" dirty="0"/>
-          </a:p>
-        </p:txBody>
-      </p:sp>
-      <p:sp>
-        <p:nvSpPr>
-          <p:cNvPr id="4" name="Slide Number Placeholder 3"/>
-          <p:cNvSpPr>
-            <a:spLocks noGrp="1"/>
-          </p:cNvSpPr>
-          <p:nvPr>
-            <p:ph type="sldNum" sz="quarter" idx="10"/>
-          </p:nvPr>
-        </p:nvSpPr>
-        <p:spPr/>
-        <p:txBody>
-          <a:bodyPr/>
-          <a:lstStyle/>
-          <a:p>
-            <a:fld id="{F7021451-1387-4CA6-816F-3879F97B5CBC}" type="slidenum">
-              <a:rPr lang="en-US"/>
-              <a:t>20</a:t>
             </a:fld>
             <a:endParaRPr lang="en-US"/>
           </a:p>
@@ -2659,360 +1858,9 @@
 </p:sld>
 </file>
 
-<file path=ppt/slides/slide12.xml><?xml version="1.0" encoding="utf-8"?>
-<p:sld xmlns:a="http://schemas.openxmlformats.org/drawingml/2006/main" xmlns:r="http://schemas.openxmlformats.org/officeDocument/2006/relationships" xmlns:p="http://schemas.openxmlformats.org/presentationml/2006/main">
-  <p:cSld name="Slide 12">
-    <p:bg>
-      <p:bgPr>
-        <a:blipFill dpi="0" rotWithShape="1">
-          <a:blip r:embed="rId1">
-            <a:lum/>
-          </a:blip>
-          <a:srcRect/>
-          <a:stretch>
-            <a:fillRect/>
-          </a:stretch>
-        </a:blipFill>
-        <a:effectLst/>
-      </p:bgPr>
-    </p:bg>
-    <p:spTree>
-      <p:nvGrpSpPr>
-        <p:cNvPr id="1" name=""/>
-        <p:cNvGrpSpPr/>
-        <p:nvPr/>
-      </p:nvGrpSpPr>
-      <p:grpSpPr>
-        <a:xfrm>
-          <a:off x="0" y="0"/>
-          <a:ext cx="0" cy="0"/>
-          <a:chOff x="0" y="0"/>
-          <a:chExt cx="0" cy="0"/>
-        </a:xfrm>
-      </p:grpSpPr>
-    </p:spTree>
-  </p:cSld>
-  <p:clrMapOvr>
-    <a:masterClrMapping/>
-  </p:clrMapOvr>
-</p:sld>
-</file>
-
-<file path=ppt/slides/slide13.xml><?xml version="1.0" encoding="utf-8"?>
-<p:sld xmlns:a="http://schemas.openxmlformats.org/drawingml/2006/main" xmlns:r="http://schemas.openxmlformats.org/officeDocument/2006/relationships" xmlns:p="http://schemas.openxmlformats.org/presentationml/2006/main">
-  <p:cSld name="Slide 13">
-    <p:bg>
-      <p:bgPr>
-        <a:blipFill dpi="0" rotWithShape="1">
-          <a:blip r:embed="rId1">
-            <a:lum/>
-          </a:blip>
-          <a:srcRect/>
-          <a:stretch>
-            <a:fillRect/>
-          </a:stretch>
-        </a:blipFill>
-        <a:effectLst/>
-      </p:bgPr>
-    </p:bg>
-    <p:spTree>
-      <p:nvGrpSpPr>
-        <p:cNvPr id="1" name=""/>
-        <p:cNvGrpSpPr/>
-        <p:nvPr/>
-      </p:nvGrpSpPr>
-      <p:grpSpPr>
-        <a:xfrm>
-          <a:off x="0" y="0"/>
-          <a:ext cx="0" cy="0"/>
-          <a:chOff x="0" y="0"/>
-          <a:chExt cx="0" cy="0"/>
-        </a:xfrm>
-      </p:grpSpPr>
-    </p:spTree>
-  </p:cSld>
-  <p:clrMapOvr>
-    <a:masterClrMapping/>
-  </p:clrMapOvr>
-</p:sld>
-</file>
-
-<file path=ppt/slides/slide14.xml><?xml version="1.0" encoding="utf-8"?>
-<p:sld xmlns:a="http://schemas.openxmlformats.org/drawingml/2006/main" xmlns:r="http://schemas.openxmlformats.org/officeDocument/2006/relationships" xmlns:p="http://schemas.openxmlformats.org/presentationml/2006/main">
-  <p:cSld name="Slide 14">
-    <p:bg>
-      <p:bgPr>
-        <a:blipFill dpi="0" rotWithShape="1">
-          <a:blip r:embed="rId1">
-            <a:lum/>
-          </a:blip>
-          <a:srcRect/>
-          <a:stretch>
-            <a:fillRect/>
-          </a:stretch>
-        </a:blipFill>
-        <a:effectLst/>
-      </p:bgPr>
-    </p:bg>
-    <p:spTree>
-      <p:nvGrpSpPr>
-        <p:cNvPr id="1" name=""/>
-        <p:cNvGrpSpPr/>
-        <p:nvPr/>
-      </p:nvGrpSpPr>
-      <p:grpSpPr>
-        <a:xfrm>
-          <a:off x="0" y="0"/>
-          <a:ext cx="0" cy="0"/>
-          <a:chOff x="0" y="0"/>
-          <a:chExt cx="0" cy="0"/>
-        </a:xfrm>
-      </p:grpSpPr>
-    </p:spTree>
-  </p:cSld>
-  <p:clrMapOvr>
-    <a:masterClrMapping/>
-  </p:clrMapOvr>
-</p:sld>
-</file>
-
-<file path=ppt/slides/slide15.xml><?xml version="1.0" encoding="utf-8"?>
-<p:sld xmlns:a="http://schemas.openxmlformats.org/drawingml/2006/main" xmlns:r="http://schemas.openxmlformats.org/officeDocument/2006/relationships" xmlns:p="http://schemas.openxmlformats.org/presentationml/2006/main">
-  <p:cSld name="Slide 15">
-    <p:bg>
-      <p:bgPr>
-        <a:blipFill dpi="0" rotWithShape="1">
-          <a:blip r:embed="rId1">
-            <a:lum/>
-          </a:blip>
-          <a:srcRect/>
-          <a:stretch>
-            <a:fillRect/>
-          </a:stretch>
-        </a:blipFill>
-        <a:effectLst/>
-      </p:bgPr>
-    </p:bg>
-    <p:spTree>
-      <p:nvGrpSpPr>
-        <p:cNvPr id="1" name=""/>
-        <p:cNvGrpSpPr/>
-        <p:nvPr/>
-      </p:nvGrpSpPr>
-      <p:grpSpPr>
-        <a:xfrm>
-          <a:off x="0" y="0"/>
-          <a:ext cx="0" cy="0"/>
-          <a:chOff x="0" y="0"/>
-          <a:chExt cx="0" cy="0"/>
-        </a:xfrm>
-      </p:grpSpPr>
-    </p:spTree>
-  </p:cSld>
-  <p:clrMapOvr>
-    <a:masterClrMapping/>
-  </p:clrMapOvr>
-</p:sld>
-</file>
-
-<file path=ppt/slides/slide16.xml><?xml version="1.0" encoding="utf-8"?>
-<p:sld xmlns:a="http://schemas.openxmlformats.org/drawingml/2006/main" xmlns:r="http://schemas.openxmlformats.org/officeDocument/2006/relationships" xmlns:p="http://schemas.openxmlformats.org/presentationml/2006/main">
-  <p:cSld name="Slide 16">
-    <p:bg>
-      <p:bgPr>
-        <a:blipFill dpi="0" rotWithShape="1">
-          <a:blip r:embed="rId1">
-            <a:lum/>
-          </a:blip>
-          <a:srcRect/>
-          <a:stretch>
-            <a:fillRect/>
-          </a:stretch>
-        </a:blipFill>
-        <a:effectLst/>
-      </p:bgPr>
-    </p:bg>
-    <p:spTree>
-      <p:nvGrpSpPr>
-        <p:cNvPr id="1" name=""/>
-        <p:cNvGrpSpPr/>
-        <p:nvPr/>
-      </p:nvGrpSpPr>
-      <p:grpSpPr>
-        <a:xfrm>
-          <a:off x="0" y="0"/>
-          <a:ext cx="0" cy="0"/>
-          <a:chOff x="0" y="0"/>
-          <a:chExt cx="0" cy="0"/>
-        </a:xfrm>
-      </p:grpSpPr>
-    </p:spTree>
-  </p:cSld>
-  <p:clrMapOvr>
-    <a:masterClrMapping/>
-  </p:clrMapOvr>
-</p:sld>
-</file>
-
-<file path=ppt/slides/slide17.xml><?xml version="1.0" encoding="utf-8"?>
-<p:sld xmlns:a="http://schemas.openxmlformats.org/drawingml/2006/main" xmlns:r="http://schemas.openxmlformats.org/officeDocument/2006/relationships" xmlns:p="http://schemas.openxmlformats.org/presentationml/2006/main">
-  <p:cSld name="Slide 17">
-    <p:bg>
-      <p:bgPr>
-        <a:blipFill dpi="0" rotWithShape="1">
-          <a:blip r:embed="rId1">
-            <a:lum/>
-          </a:blip>
-          <a:srcRect/>
-          <a:stretch>
-            <a:fillRect/>
-          </a:stretch>
-        </a:blipFill>
-        <a:effectLst/>
-      </p:bgPr>
-    </p:bg>
-    <p:spTree>
-      <p:nvGrpSpPr>
-        <p:cNvPr id="1" name=""/>
-        <p:cNvGrpSpPr/>
-        <p:nvPr/>
-      </p:nvGrpSpPr>
-      <p:grpSpPr>
-        <a:xfrm>
-          <a:off x="0" y="0"/>
-          <a:ext cx="0" cy="0"/>
-          <a:chOff x="0" y="0"/>
-          <a:chExt cx="0" cy="0"/>
-        </a:xfrm>
-      </p:grpSpPr>
-    </p:spTree>
-  </p:cSld>
-  <p:clrMapOvr>
-    <a:masterClrMapping/>
-  </p:clrMapOvr>
-</p:sld>
-</file>
-
-<file path=ppt/slides/slide18.xml><?xml version="1.0" encoding="utf-8"?>
-<p:sld xmlns:a="http://schemas.openxmlformats.org/drawingml/2006/main" xmlns:r="http://schemas.openxmlformats.org/officeDocument/2006/relationships" xmlns:p="http://schemas.openxmlformats.org/presentationml/2006/main">
-  <p:cSld name="Slide 18">
-    <p:bg>
-      <p:bgPr>
-        <a:blipFill dpi="0" rotWithShape="1">
-          <a:blip r:embed="rId1">
-            <a:lum/>
-          </a:blip>
-          <a:srcRect/>
-          <a:stretch>
-            <a:fillRect/>
-          </a:stretch>
-        </a:blipFill>
-        <a:effectLst/>
-      </p:bgPr>
-    </p:bg>
-    <p:spTree>
-      <p:nvGrpSpPr>
-        <p:cNvPr id="1" name=""/>
-        <p:cNvGrpSpPr/>
-        <p:nvPr/>
-      </p:nvGrpSpPr>
-      <p:grpSpPr>
-        <a:xfrm>
-          <a:off x="0" y="0"/>
-          <a:ext cx="0" cy="0"/>
-          <a:chOff x="0" y="0"/>
-          <a:chExt cx="0" cy="0"/>
-        </a:xfrm>
-      </p:grpSpPr>
-    </p:spTree>
-  </p:cSld>
-  <p:clrMapOvr>
-    <a:masterClrMapping/>
-  </p:clrMapOvr>
-</p:sld>
-</file>
-
-<file path=ppt/slides/slide19.xml><?xml version="1.0" encoding="utf-8"?>
-<p:sld xmlns:a="http://schemas.openxmlformats.org/drawingml/2006/main" xmlns:r="http://schemas.openxmlformats.org/officeDocument/2006/relationships" xmlns:p="http://schemas.openxmlformats.org/presentationml/2006/main">
-  <p:cSld name="Slide 19">
-    <p:bg>
-      <p:bgPr>
-        <a:blipFill dpi="0" rotWithShape="1">
-          <a:blip r:embed="rId1">
-            <a:lum/>
-          </a:blip>
-          <a:srcRect/>
-          <a:stretch>
-            <a:fillRect/>
-          </a:stretch>
-        </a:blipFill>
-        <a:effectLst/>
-      </p:bgPr>
-    </p:bg>
-    <p:spTree>
-      <p:nvGrpSpPr>
-        <p:cNvPr id="1" name=""/>
-        <p:cNvGrpSpPr/>
-        <p:nvPr/>
-      </p:nvGrpSpPr>
-      <p:grpSpPr>
-        <a:xfrm>
-          <a:off x="0" y="0"/>
-          <a:ext cx="0" cy="0"/>
-          <a:chOff x="0" y="0"/>
-          <a:chExt cx="0" cy="0"/>
-        </a:xfrm>
-      </p:grpSpPr>
-    </p:spTree>
-  </p:cSld>
-  <p:clrMapOvr>
-    <a:masterClrMapping/>
-  </p:clrMapOvr>
-</p:sld>
-</file>
-
 <file path=ppt/slides/slide2.xml><?xml version="1.0" encoding="utf-8"?>
 <p:sld xmlns:a="http://schemas.openxmlformats.org/drawingml/2006/main" xmlns:r="http://schemas.openxmlformats.org/officeDocument/2006/relationships" xmlns:p="http://schemas.openxmlformats.org/presentationml/2006/main">
   <p:cSld name="Slide 2">
-    <p:bg>
-      <p:bgPr>
-        <a:blipFill dpi="0" rotWithShape="1">
-          <a:blip r:embed="rId1">
-            <a:lum/>
-          </a:blip>
-          <a:srcRect/>
-          <a:stretch>
-            <a:fillRect/>
-          </a:stretch>
-        </a:blipFill>
-        <a:effectLst/>
-      </p:bgPr>
-    </p:bg>
-    <p:spTree>
-      <p:nvGrpSpPr>
-        <p:cNvPr id="1" name=""/>
-        <p:cNvGrpSpPr/>
-        <p:nvPr/>
-      </p:nvGrpSpPr>
-      <p:grpSpPr>
-        <a:xfrm>
-          <a:off x="0" y="0"/>
-          <a:ext cx="0" cy="0"/>
-          <a:chOff x="0" y="0"/>
-          <a:chExt cx="0" cy="0"/>
-        </a:xfrm>
-      </p:grpSpPr>
-    </p:spTree>
-  </p:cSld>
-  <p:clrMapOvr>
-    <a:masterClrMapping/>
-  </p:clrMapOvr>
-</p:sld>
-</file>
-
-<file path=ppt/slides/slide20.xml><?xml version="1.0" encoding="utf-8"?>
-<p:sld xmlns:a="http://schemas.openxmlformats.org/drawingml/2006/main" xmlns:r="http://schemas.openxmlformats.org/officeDocument/2006/relationships" xmlns:p="http://schemas.openxmlformats.org/presentationml/2006/main">
-  <p:cSld name="Slide 20">
     <p:bg>
       <p:bgPr>
         <a:blipFill dpi="0" rotWithShape="1">

</xml_diff>

<commit_message>
Reframe deck around AI-development knowledge sharing
Shift the deck's purpose from "app report" to sharing transferable
knowledge about developing with AI, with the app as the example rather
than the subject.

- Retitle to "AIを使った開発の知見共有"; add a framing slide stating the
  app is only the 題材
- Compress app/requirements into one short 題材 slide
- Recast the learnings as transferable 知見 (verify AI output; "works"
  vs "correct"; data prep is the bottleneck; the human role shifts from
  implementation to judgment)
- まとめ summarizes the practical takeaways for using AI; 10 slides total

Co-Authored-By: Claude Opus 4.8 <noreply@anthropic.com>
Claude-Session: https://claude.ai/code/session_01728TbJKawDnZ2kxeR4TCwy
</commit_message>
<xml_diff>
--- a/docs/slides.pptx
+++ b/docs/slides.pptx
@@ -15,10 +15,9 @@
     <p:sldId id="263" r:id="rId9"/>
     <p:sldId id="264" r:id="rId10"/>
     <p:sldId id="265" r:id="rId11"/>
-    <p:sldId id="266" r:id="rId12"/>
   </p:sldIdLst>
   <p:notesMasterIdLst>
-    <p:notesMasterId r:id="rId13"/>
+    <p:notesMasterId r:id="rId12"/>
   </p:notesMasterIdLst>
   <p:sldSz cx="12192000" cy="6858000"/>
   <p:notesSz cx="6858000" cy="12192000"/>
@@ -624,94 +623,6 @@
             <a:fld id="{F7021451-1387-4CA6-816F-3879F97B5CBC}" type="slidenum">
               <a:rPr lang="en-US"/>
               <a:t>10</a:t>
-            </a:fld>
-            <a:endParaRPr lang="en-US"/>
-          </a:p>
-        </p:txBody>
-      </p:sp>
-    </p:spTree>
-    <p:extLst>
-      <p:ext uri="{BB962C8B-B14F-4D97-AF65-F5344CB8AC3E}">
-        <p14:creationId xmlns:p14="http://schemas.microsoft.com/office/powerpoint/2010/main" val="1024086991"/>
-      </p:ext>
-    </p:extLst>
-  </p:cSld>
-  <p:clrMapOvr>
-    <a:masterClrMapping/>
-  </p:clrMapOvr>
-</p:notes>
-</file>
-
-<file path=ppt/notesSlides/notesSlide11.xml><?xml version="1.0" encoding="utf-8"?>
-<p:notes xmlns:a="http://schemas.openxmlformats.org/drawingml/2006/main" xmlns:r="http://schemas.openxmlformats.org/officeDocument/2006/relationships" xmlns:p="http://schemas.openxmlformats.org/presentationml/2006/main">
-  <p:cSld>
-    <p:spTree>
-      <p:nvGrpSpPr>
-        <p:cNvPr id="1" name=""/>
-        <p:cNvGrpSpPr/>
-        <p:nvPr/>
-      </p:nvGrpSpPr>
-      <p:grpSpPr>
-        <a:xfrm>
-          <a:off x="0" y="0"/>
-          <a:ext cx="0" cy="0"/>
-          <a:chOff x="0" y="0"/>
-          <a:chExt cx="0" cy="0"/>
-        </a:xfrm>
-      </p:grpSpPr>
-      <p:sp>
-        <p:nvSpPr>
-          <p:cNvPr id="2" name="Slide Image Placeholder 1"/>
-          <p:cNvSpPr>
-            <a:spLocks noGrp="1" noRot="1" noChangeAspect="1"/>
-          </p:cNvSpPr>
-          <p:nvPr>
-            <p:ph type="sldImg"/>
-          </p:nvPr>
-        </p:nvSpPr>
-        <p:spPr/>
-      </p:sp>
-      <p:sp>
-        <p:nvSpPr>
-          <p:cNvPr id="3" name="Notes Placeholder 2"/>
-          <p:cNvSpPr>
-            <a:spLocks noGrp="1"/>
-          </p:cNvSpPr>
-          <p:nvPr>
-            <p:ph type="body" idx="1"/>
-          </p:nvPr>
-        </p:nvSpPr>
-        <p:spPr/>
-        <p:txBody>
-          <a:bodyPr/>
-          <a:lstStyle/>
-          <a:p>
-            <a:r>
-              <a:rPr lang="en-US" dirty="0"/>
-              <a:t/>
-            </a:r>
-            <a:endParaRPr lang="en-US" dirty="0"/>
-          </a:p>
-        </p:txBody>
-      </p:sp>
-      <p:sp>
-        <p:nvSpPr>
-          <p:cNvPr id="4" name="Slide Number Placeholder 3"/>
-          <p:cNvSpPr>
-            <a:spLocks noGrp="1"/>
-          </p:cNvSpPr>
-          <p:nvPr>
-            <p:ph type="sldNum" sz="quarter" idx="10"/>
-          </p:nvPr>
-        </p:nvSpPr>
-        <p:spPr/>
-        <p:txBody>
-          <a:bodyPr/>
-          <a:lstStyle/>
-          <a:p>
-            <a:fld id="{F7021451-1387-4CA6-816F-3879F97B5CBC}" type="slidenum">
-              <a:rPr lang="en-US"/>
-              <a:t>11</a:t>
             </a:fld>
             <a:endParaRPr lang="en-US"/>
           </a:p>
@@ -1783,45 +1694,6 @@
 <file path=ppt/slides/slide10.xml><?xml version="1.0" encoding="utf-8"?>
 <p:sld xmlns:a="http://schemas.openxmlformats.org/drawingml/2006/main" xmlns:r="http://schemas.openxmlformats.org/officeDocument/2006/relationships" xmlns:p="http://schemas.openxmlformats.org/presentationml/2006/main">
   <p:cSld name="Slide 10">
-    <p:bg>
-      <p:bgPr>
-        <a:blipFill dpi="0" rotWithShape="1">
-          <a:blip r:embed="rId1">
-            <a:lum/>
-          </a:blip>
-          <a:srcRect/>
-          <a:stretch>
-            <a:fillRect/>
-          </a:stretch>
-        </a:blipFill>
-        <a:effectLst/>
-      </p:bgPr>
-    </p:bg>
-    <p:spTree>
-      <p:nvGrpSpPr>
-        <p:cNvPr id="1" name=""/>
-        <p:cNvGrpSpPr/>
-        <p:nvPr/>
-      </p:nvGrpSpPr>
-      <p:grpSpPr>
-        <a:xfrm>
-          <a:off x="0" y="0"/>
-          <a:ext cx="0" cy="0"/>
-          <a:chOff x="0" y="0"/>
-          <a:chExt cx="0" cy="0"/>
-        </a:xfrm>
-      </p:grpSpPr>
-    </p:spTree>
-  </p:cSld>
-  <p:clrMapOvr>
-    <a:masterClrMapping/>
-  </p:clrMapOvr>
-</p:sld>
-</file>
-
-<file path=ppt/slides/slide11.xml><?xml version="1.0" encoding="utf-8"?>
-<p:sld xmlns:a="http://schemas.openxmlformats.org/drawingml/2006/main" xmlns:r="http://schemas.openxmlformats.org/officeDocument/2006/relationships" xmlns:p="http://schemas.openxmlformats.org/presentationml/2006/main">
-  <p:cSld name="Slide 11">
     <p:bg>
       <p:bgPr>
         <a:blipFill dpi="0" rotWithShape="1">

</xml_diff>